<commit_message>
docs(presentations): regenerate slides from qmd (Models using facts)
Re-render the quarto outputs so the slide text matches the updated
source: "Models using facts" instead of "Models using TLM".

Regenerated with quarto 1.10.18:
- introduction.html  (revealjs)
- introduction.pptx
- introduction.pdf   (beamer/lualatex)

The introduction.key (Keynote) and caseum-introduction-360p.mp4
exports are not quarto outputs and still carry the old wording;
they need a manual Keynote re-export and re-record.

Assisted-by: Claude:claude-opus-4-8
Co-Authored-By: lsimons-bot <bot@leosimons.com>
</commit_message>
<xml_diff>
--- a/docs/presentations/introduction.pptx
+++ b/docs/presentations/introduction.pptx
@@ -4919,7 +4919,7 @@
             </a:r>
             <a:r>
               <a:rPr/>
-              <a:t>odels using TLM</a:t>
+              <a:t>odels using facts</a:t>
             </a:r>
           </a:p>
         </p:txBody>
@@ -6575,7 +6575,7 @@
       </p:sp>
       <p:pic>
         <p:nvPicPr>
-          <p:cNvPr descr="../models/tlm-model-example.png" id="0" name="Picture 1"/>
+          <p:cNvPr descr="../models/model-example.png" id="0" name="Picture 1"/>
           <p:cNvPicPr>
             <a:picLocks noGrp="1" noChangeAspect="1"/>
           </p:cNvPicPr>

</xml_diff>